<commit_message>
test: Split a planted value across pptx runs
</commit_message>
<xml_diff>
--- a/testdata/slides.pptx
+++ b/testdata/slides.pptx
@@ -4092,7 +4092,11 @@
             </a:pPr>
             <a:r>
               <a:rPr/>
-              <a:t>Jean Dupont</a:t>
+              <a:t>Jean </a:t>
+            </a:r>
+            <a:r>
+              <a:rPr b="1"/>
+              <a:t>Dupont</a:t>
             </a:r>
           </a:p>
         </p:txBody>

</xml_diff>